<commit_message>
Werkcollege 3 toegevoegd: vijf ontwerpen met AI
Studenten laten een AI-assistent vijf uitingen ontwerpen die op vijf assen
maximaal verschillen, en kiezen daarna zelf onderbouwd. De prompt verbiedt een
aanbeveling en vraagt per ontwerp waar het faalt, zodat er iets te kiezen valt.

Ook twee correcties in de eerdere werkcolleges: peer review is nu expliciet
(tijdens de sessie zijn er geen opdrachtgevers, dus studenten toetsen elkaar),
en "ketting" is overal "keten" geworden.

Co-Authored-By: Claude Opus 5 <noreply@anthropic.com>
</commit_message>
<xml_diff>
--- a/Werkcollege-2-waar-gaat-jouw-advies-heen.pptx
+++ b/Werkcollege-2-waar-gaat-jouw-advies-heen.pptx
@@ -859,7 +859,7 @@
           <a:lstStyle/>
           <a:p>
             <a:r>
-              <a:t>Laatste ronde. Kies een van de drie personen uit je ketting. Bedenk wat jouw opdrachtgever aan die persoon moet kunnen laten zien: een pagina, een cijfer, een plaatje. Schets dat op werkblad 2 en schrijf de zin erbij die je opdrachtgever erover zegt, want dat dwingt je scherp te zijn. Toets het daarna bij iemand anders.  [18:00 - 26:00]</a:t>
+              <a:t>Laatste ronde. Kies een van de drie personen uit je keten. Bedenk wat jouw opdrachtgever aan die persoon moet kunnen laten zien: een pagina, een cijfer, een plaatje. Schets dat op werkblad 2 en schrijf de zin erbij die je opdrachtgever erover zegt, want dat dwingt je scherp te zijn. Toets het daarna bij een medestudent die je vraagt die rol te spelen.  [18:00 - 26:00]</a:t>
             </a:r>
           </a:p>
         </p:txBody>
@@ -999,7 +999,7 @@
           <a:lstStyle/>
           <a:p>
             <a:r>
-              <a:t>Zet je ketting in je plan van aanpak of in je verantwoording: wie krijgt het na je opdrachtgever, in welke context, en wat heb je voor die persoon gemaakt. Twee of drie regels is genoeg. En vraag het je opdrachtgever gewoon: met wie ga jij dit delen? Dat is meteen een goed gesprek.  [28:30 - 30:00]</a:t>
+              <a:t>Zet je keten in je plan van aanpak of in je verantwoording: wie krijgt het na je opdrachtgever, in welke context, en wat heb je voor die persoon gemaakt. Twee of drie regels is genoeg. En vraag het je opdrachtgever gewoon: met wie ga jij dit delen? Dat is meteen een goed gesprek.  [28:30 - 30:00]</a:t>
             </a:r>
           </a:p>
         </p:txBody>
@@ -4757,7 +4757,7 @@
                 </a:solidFill>
                 <a:latin typeface="Courier New"/>
               </a:rPr>
-              <a:t>01 · DE KETTING</a:t>
+              <a:t>01 · DE KETEN</a:t>
             </a:r>
           </a:p>
         </p:txBody>
@@ -7772,7 +7772,7 @@
                 </a:solidFill>
                 <a:latin typeface="Arial"/>
               </a:rPr>
-              <a:t>Daarna: check elkaars ketting in tweetallen.</a:t>
+              <a:t>Daarna: check elkaars keten in tweetallen.</a:t>
             </a:r>
           </a:p>
         </p:txBody>
@@ -9407,7 +9407,7 @@
                 </a:solidFill>
                 <a:latin typeface="Arial"/>
               </a:rPr>
-              <a:t> uit je ketting van net.</a:t>
+              <a:t> uit je keten van net.</a:t>
             </a:r>
           </a:p>
         </p:txBody>
@@ -9726,7 +9726,7 @@
                 </a:solidFill>
                 <a:latin typeface="Arial"/>
               </a:rPr>
-              <a:t>Toets: stelt je toetser meteen de vraag die jij had opgeschreven?</a:t>
+              <a:t>Toets bij een medestudent: laat hem die rol spelen. Stelt hij meteen jouw vraag?</a:t>
             </a:r>
           </a:p>
         </p:txBody>
@@ -11104,7 +11104,7 @@
                 </a:solidFill>
                 <a:latin typeface="Arial Black"/>
               </a:rPr>
-              <a:t>NEEM JE KETTING MEE.</a:t>
+              <a:t>NEEM JE KETEN MEE.</a:t>
             </a:r>
           </a:p>
         </p:txBody>

</xml_diff>